<commit_message>
sync docs/ from travplan@fab842f
</commit_message>
<xml_diff>
--- a/slides/study-overview/study-overview.pptx
+++ b/slides/study-overview/study-overview.pptx
@@ -876,7 +876,7 @@
           <a:lstStyle/>
           <a:p>
             <a:r>
-              <a:t>한 주기는 다섯 단계다: 지난 해를 한 스텝 당겨 warm start, 노이즈를 더해 K개 후보, 후보마다 rollout해 비용 S_k, 지수 가중치, 가중평균의 첫 제어만 실행. 최솟값 ρ를 빼지 않으면 모든 후보가 치명 페널티(1000)를 받을 때 0/0이 된다. 함정: λ는 비용의 절대 크기에 따라 달라지고, 후보가 모두 나쁜 곳에 있으면 평균도 나쁘며, 두 무리 사이로 평균이 떨어질 수 있다. 유효 샘플 수 1/Σw²는 λ = 0.5에서 1.27, λ = 2에서 2.38이다. 코드: control/mppi/mppi.py, smooth.py.</a:t>
+              <a:t>한 주기는 다섯 단계다: 지난 해를 한 스텝 당겨 warm start, 노이즈를 더해 K개 후보, 후보마다 rollout해 비용 S_k, 지수 가중치, 가중평균의 첫 제어만 실행. 최솟값 ρ를 빼지 않으면 모든 후보가 치명 페널티(1000)를 받을 때 0/0이 된다. 함정: λ는 비용의 절대 크기에 따라 달라지고, 후보가 모두 나쁜 곳에 있으면 평균도 나쁘며, 두 무리 사이로 평균이 떨어질 수 있다. 유효 샘플 수 1/Σw²는 λ = 0.5에서 1.27, λ = 2에서 2.38이다. MPPIConfig 기본값은 후보 K 768, horizon T × dt 40 × 0.1 s, 온도 λ 0.5, 경로 추종 후보 30 %다. 코드: control/mppi/mppi.py, smooth.py. 영상에서는 정보이론적 MPPI가 AutoRally를 흙길 트랙에서 공격적으로 모는 것을 본다([14]의 학회판, Williams 외 ICRA 2017의 영상이다).</a:t>
             </a:r>
           </a:p>
         </p:txBody>
@@ -1016,7 +1016,7 @@
           <a:lstStyle/>
           <a:p>
             <a:r>
-              <a:t>NMPC는 기울기로 풀기 때문에 계단 모양 비용(치명 셀)에서 방향을 얻지 못한다. 대신 hard 제약, 튜브, 확률 제약을 품는다. 표의 수치는 travplan 권장 L1 + 스워브 plant 조건, 레벨 3 seed 10 × 오프셋 3 × 지형 4(TP-0150, TP-0152)다. 지금은 MPPI 갈래가 앞서지만, 혼돈 조건이라 짝 비교와 잡음 바닥으로 판정해야 한다(CLAUDE.md 2층 게이트). 코드: control/acados_mpc/.</a:t>
+              <a:t>NMPC는 기울기로 풀기 때문에 계단 모양 비용(치명 셀)에서 방향을 얻지 못한다. 대신 hard 제약, 튜브, 확률 제약을 품는다. plant L1 레벨 3 도달(치명)은 mppi_plant_lag 239/360 (4), mpc 222/360 (34), mpc_gp 215/360 (32)이다. 조건은 travplan 권장 L1 + 스워브 plant, 레벨 3 seed 10 × 오프셋 3 × 지형 4(TP-0150, TP-0152)다. 지금은 MPPI 갈래가 앞서지만, 혼돈 조건이라 짝 비교와 잡음 바닥으로 판정해야 한다(CLAUDE.md 2층 게이트). 코드: control/acados_mpc/. 영상에서는 처음엔 모델 오차로 충돌하던 RC 경주차가 GP로 잔차를 배운 뒤 더 빠르고 안전하게 도는 것을 본다.</a:t>
             </a:r>
           </a:p>
         </p:txBody>
@@ -1366,7 +1366,7 @@
           <a:lstStyle/>
           <a:p>
             <a:r>
-              <a:t>CVaR는 볼록이라 h가 아핀이고 샘플이 유한하면 제약을 선형 계획/QP로 풀 수 있다. Adaptive CVaR-BF는 CasADi 구현이 공개돼 있어 travplan의 acados 트랙과도 맞는다. 위험 중립 barrier는 기대값 E[h] ≥ (1−γ)h만 지키므로 실제 샘플의 일부는 h &lt; 0으로 떨어진다. 그것이 그림 (b)다.</a:t>
+              <a:t>CVaR는 볼록이라 h가 아핀이고 샘플이 유한하면 제약을 선형 계획/QP로 풀 수 있다. Adaptive CVaR-BF는 CasADi 구현이 공개돼 있어 travplan의 acados 트랙과도 맞는다. 위험 중립 barrier는 기대값 E[h] ≥ (1−γ)h만 지키므로 실제 샘플의 일부는 h &lt; 0으로 떨어진다. 그것이 그림 (b)다. 영상에서는 적응 CVaR-BF가 군중 속에서 위험 수준 β를 바꿔 가며 보행자 사이를 지나는 것을 본다.</a:t>
             </a:r>
           </a:p>
         </p:txBody>
@@ -1926,7 +1926,7 @@
           <a:lstStyle/>
           <a:p>
             <a:r>
-              <a:t>분산이 작은 쪽을 더 믿는 정밀도 가중 평균이다. 측정 분산이 거리 제곱에 비례하므로 먼 점은 적게 반영된다. 이상치는 Mahalanobis 거리로 버린다. 상한 층이 핵심: 광선이 관측되지 않은 셀 위를 지나가면 그 셀의 지면은 광선 높이보다 낮다. travplan L1(--perception l1)은 이 코드의 코어를 쓰고, TP-0146에서 매퍼 격자가 반 셀 어긋난 래퍼 버그를 고쳤다.</a:t>
+              <a:t>분산이 작은 쪽을 더 믿는 정밀도 가중 평균이다. 측정 분산이 거리 제곱에 비례하므로 먼 점은 적게 반영된다. 이상치는 Mahalanobis 거리로 버린다. 상한 층이 핵심: 광선이 관측되지 않은 셀 위를 지나가면 그 셀의 지면은 광선 높이보다 낮다. travplan L1(--perception l1)은 이 코드의 코어를 쓰고, TP-0146에서 매퍼 격자가 반 셀 어긋난 래퍼 버그를 고쳤다. [3]의 GPU 파이프라인 그림(Fig. 1)은 인식 문서 A.1에 있다. 영상에서는 StarlETH가 걸으며 로봇 중심 높이 지도가 셀마다 갱신되는 것을 본다.</a:t>
             </a:r>
           </a:p>
         </p:txBody>
@@ -2066,7 +2066,7 @@
           <a:lstStyle/>
           <a:p>
             <a:r>
-              <a:t>거리 d에 있는 관측을 k(d)개의 관측으로 세는 우도는 임의의 규칙이 아니다. Vega-Brown 등은 가까우면 비슷하다는 매끄러움 제약 아래 이것이 자연스럽게 나온다는 것을 보였다. 켤레 사전분포를 쓰면 사후가 닫힌 식이라 GPU 격자에서 빠르다. travplan의 fill_unknown과 비교하면, BKI는 채운 값과 함께 얼마나 믿을지를 준다는 점이 다르다.</a:t>
+              <a:t>거리 d에 있는 관측을 k(d)개의 관측으로 세는 우도는 임의의 규칙이 아니다. Vega-Brown 등은 가까우면 비슷하다는 매끄러움 제약 아래 이것이 자연스럽게 나온다는 것을 보였다. 켤레 사전분포를 쓰면 사후가 닫힌 식이라 GPU 격자에서 빠르다. travplan의 fill_unknown과 비교하면, BKI는 채운 값과 함께 얼마나 믿을지를 준다는 점이 다르다. 영상에서는 Cassie Blue의 LiDAR·카메라 관측이 BKI로 합쳐져 시맨틱 지도가 실시간으로 쌓이고, 그 지도에서 보도 칸만 골라 길을 찾는 것을 본다.</a:t>
             </a:r>
           </a:p>
         </p:txBody>
@@ -5446,6 +5446,54 @@
           </a:prstGeom>
         </p:spPr>
       </p:pic>
+      <p:sp>
+        <p:nvSpPr>
+          <p:cNvPr id="3" name="YouTube">
+            <a:hlinkClick r:id="rId3"/>
+          </p:cNvPr>
+          <p:cNvSpPr/>
+          <p:nvPr/>
+        </p:nvSpPr>
+        <p:spPr>
+          <a:xfrm>
+            <a:off x="7696200" y="1675110"/>
+            <a:ext cx="3175000" cy="1784350"/>
+          </a:xfrm>
+          <a:prstGeom prst="rect">
+            <a:avLst/>
+          </a:prstGeom>
+          <a:solidFill>
+            <a:srgbClr val="FFFFFF">
+              <a:alpha val="0"/>
+            </a:srgbClr>
+          </a:solidFill>
+          <a:ln>
+            <a:noFill/>
+          </a:ln>
+          <a:effectLst/>
+        </p:spPr>
+        <p:style>
+          <a:lnRef idx="1">
+            <a:schemeClr val="accent1"/>
+          </a:lnRef>
+          <a:fillRef idx="3">
+            <a:schemeClr val="accent1"/>
+          </a:fillRef>
+          <a:effectRef idx="2">
+            <a:schemeClr val="accent1"/>
+          </a:effectRef>
+          <a:fontRef idx="minor">
+            <a:schemeClr val="lt1"/>
+          </a:fontRef>
+        </p:style>
+        <p:txBody>
+          <a:bodyPr rtlCol="0" anchor="ctr"/>
+          <a:lstStyle/>
+          <a:p>
+            <a:pPr algn="ctr"/>
+          </a:p>
+        </p:txBody>
+      </p:sp>
     </p:spTree>
   </p:cSld>
   <p:clrMapOvr>
@@ -5530,6 +5578,54 @@
           </a:prstGeom>
         </p:spPr>
       </p:pic>
+      <p:sp>
+        <p:nvSpPr>
+          <p:cNvPr id="3" name="YouTube">
+            <a:hlinkClick r:id="rId3"/>
+          </p:cNvPr>
+          <p:cNvSpPr/>
+          <p:nvPr/>
+        </p:nvSpPr>
+        <p:spPr>
+          <a:xfrm>
+            <a:off x="7696200" y="1675110"/>
+            <a:ext cx="3048000" cy="1714500"/>
+          </a:xfrm>
+          <a:prstGeom prst="rect">
+            <a:avLst/>
+          </a:prstGeom>
+          <a:solidFill>
+            <a:srgbClr val="FFFFFF">
+              <a:alpha val="0"/>
+            </a:srgbClr>
+          </a:solidFill>
+          <a:ln>
+            <a:noFill/>
+          </a:ln>
+          <a:effectLst/>
+        </p:spPr>
+        <p:style>
+          <a:lnRef idx="1">
+            <a:schemeClr val="accent1"/>
+          </a:lnRef>
+          <a:fillRef idx="3">
+            <a:schemeClr val="accent1"/>
+          </a:fillRef>
+          <a:effectRef idx="2">
+            <a:schemeClr val="accent1"/>
+          </a:effectRef>
+          <a:fontRef idx="minor">
+            <a:schemeClr val="lt1"/>
+          </a:fontRef>
+        </p:style>
+        <p:txBody>
+          <a:bodyPr rtlCol="0" anchor="ctr"/>
+          <a:lstStyle/>
+          <a:p>
+            <a:pPr algn="ctr"/>
+          </a:p>
+        </p:txBody>
+      </p:sp>
     </p:spTree>
   </p:cSld>
   <p:clrMapOvr>
@@ -5740,6 +5836,54 @@
           </a:prstGeom>
         </p:spPr>
       </p:pic>
+      <p:sp>
+        <p:nvSpPr>
+          <p:cNvPr id="3" name="YouTube">
+            <a:hlinkClick r:id="rId3"/>
+          </p:cNvPr>
+          <p:cNvSpPr/>
+          <p:nvPr/>
+        </p:nvSpPr>
+        <p:spPr>
+          <a:xfrm>
+            <a:off x="8966200" y="1675110"/>
+            <a:ext cx="2413000" cy="1358900"/>
+          </a:xfrm>
+          <a:prstGeom prst="rect">
+            <a:avLst/>
+          </a:prstGeom>
+          <a:solidFill>
+            <a:srgbClr val="FFFFFF">
+              <a:alpha val="0"/>
+            </a:srgbClr>
+          </a:solidFill>
+          <a:ln>
+            <a:noFill/>
+          </a:ln>
+          <a:effectLst/>
+        </p:spPr>
+        <p:style>
+          <a:lnRef idx="1">
+            <a:schemeClr val="accent1"/>
+          </a:lnRef>
+          <a:fillRef idx="3">
+            <a:schemeClr val="accent1"/>
+          </a:fillRef>
+          <a:effectRef idx="2">
+            <a:schemeClr val="accent1"/>
+          </a:effectRef>
+          <a:fontRef idx="minor">
+            <a:schemeClr val="lt1"/>
+          </a:fontRef>
+        </p:style>
+        <p:txBody>
+          <a:bodyPr rtlCol="0" anchor="ctr"/>
+          <a:lstStyle/>
+          <a:p>
+            <a:pPr algn="ctr"/>
+          </a:p>
+        </p:txBody>
+      </p:sp>
     </p:spTree>
   </p:cSld>
   <p:clrMapOvr>
@@ -6076,6 +6220,54 @@
           </a:prstGeom>
         </p:spPr>
       </p:pic>
+      <p:sp>
+        <p:nvSpPr>
+          <p:cNvPr id="3" name="YouTube">
+            <a:hlinkClick r:id="rId3"/>
+          </p:cNvPr>
+          <p:cNvSpPr/>
+          <p:nvPr/>
+        </p:nvSpPr>
+        <p:spPr>
+          <a:xfrm>
+            <a:off x="7823200" y="1700510"/>
+            <a:ext cx="3556000" cy="2000250"/>
+          </a:xfrm>
+          <a:prstGeom prst="rect">
+            <a:avLst/>
+          </a:prstGeom>
+          <a:solidFill>
+            <a:srgbClr val="FFFFFF">
+              <a:alpha val="0"/>
+            </a:srgbClr>
+          </a:solidFill>
+          <a:ln>
+            <a:noFill/>
+          </a:ln>
+          <a:effectLst/>
+        </p:spPr>
+        <p:style>
+          <a:lnRef idx="1">
+            <a:schemeClr val="accent1"/>
+          </a:lnRef>
+          <a:fillRef idx="3">
+            <a:schemeClr val="accent1"/>
+          </a:fillRef>
+          <a:effectRef idx="2">
+            <a:schemeClr val="accent1"/>
+          </a:effectRef>
+          <a:fontRef idx="minor">
+            <a:schemeClr val="lt1"/>
+          </a:fontRef>
+        </p:style>
+        <p:txBody>
+          <a:bodyPr rtlCol="0" anchor="ctr"/>
+          <a:lstStyle/>
+          <a:p>
+            <a:pPr algn="ctr"/>
+          </a:p>
+        </p:txBody>
+      </p:sp>
     </p:spTree>
   </p:cSld>
   <p:clrMapOvr>
@@ -6160,6 +6352,54 @@
           </a:prstGeom>
         </p:spPr>
       </p:pic>
+      <p:sp>
+        <p:nvSpPr>
+          <p:cNvPr id="3" name="YouTube">
+            <a:hlinkClick r:id="rId3"/>
+          </p:cNvPr>
+          <p:cNvSpPr/>
+          <p:nvPr/>
+        </p:nvSpPr>
+        <p:spPr>
+          <a:xfrm>
+            <a:off x="7442200" y="1700510"/>
+            <a:ext cx="3302000" cy="1860550"/>
+          </a:xfrm>
+          <a:prstGeom prst="rect">
+            <a:avLst/>
+          </a:prstGeom>
+          <a:solidFill>
+            <a:srgbClr val="FFFFFF">
+              <a:alpha val="0"/>
+            </a:srgbClr>
+          </a:solidFill>
+          <a:ln>
+            <a:noFill/>
+          </a:ln>
+          <a:effectLst/>
+        </p:spPr>
+        <p:style>
+          <a:lnRef idx="1">
+            <a:schemeClr val="accent1"/>
+          </a:lnRef>
+          <a:fillRef idx="3">
+            <a:schemeClr val="accent1"/>
+          </a:fillRef>
+          <a:effectRef idx="2">
+            <a:schemeClr val="accent1"/>
+          </a:effectRef>
+          <a:fontRef idx="minor">
+            <a:schemeClr val="lt1"/>
+          </a:fontRef>
+        </p:style>
+        <p:txBody>
+          <a:bodyPr rtlCol="0" anchor="ctr"/>
+          <a:lstStyle/>
+          <a:p>
+            <a:pPr algn="ctr"/>
+          </a:p>
+        </p:txBody>
+      </p:sp>
     </p:spTree>
   </p:cSld>
   <p:clrMapOvr>

</xml_diff>